<commit_message>
Update presentation template: site footer on every slide, email/phone/website on first + last, drop LinkedIn
</commit_message>
<xml_diff>
--- a/presentations/Arjun-Thakur-Presentation-Template.pptx
+++ b/presentations/Arjun-Thakur-Presentation-Template.pptx
@@ -510,7 +510,7 @@
           <a:p>
             <a:r>
               <a:rPr lang="en-US" dirty="0"/>
-              <a:t>TITLE SLIDE. Replace 'Presentation Title', the kicker (CATEGORY · TRACK), and the subtitle. Name / role / contact are your fixed brand — leave as is.</a:t>
+              <a:t>TITLE SLIDE. Replace title, kicker, subtitle. Email + phone shown here and on the final slide. arjunthakur.dev is the footer on every slide.</a:t>
             </a:r>
             <a:endParaRPr lang="en-US" dirty="0"/>
           </a:p>
@@ -598,7 +598,7 @@
           <a:p>
             <a:r>
               <a:rPr lang="en-US" dirty="0"/>
-              <a:t>AGENDA SLIDE. Bullets fade in one per click. Update the item count in the card.</a:t>
+              <a:t>AGENDA. Bullets fade in one per click.</a:t>
             </a:r>
             <a:endParaRPr lang="en-US" dirty="0"/>
           </a:p>
@@ -686,7 +686,7 @@
           <a:p>
             <a:r>
               <a:rPr lang="en-US" dirty="0"/>
-              <a:t>SECTION DIVIDER. Duplicate for each new section; change the number, kicker, and title.</a:t>
+              <a:t>SECTION DIVIDER. Duplicate per section; change number, kicker, title.</a:t>
             </a:r>
             <a:endParaRPr lang="en-US" dirty="0"/>
           </a:p>
@@ -774,7 +774,7 @@
           <a:p>
             <a:r>
               <a:rPr lang="en-US" dirty="0"/>
-              <a:t>CONTENT SLIDE (image right). Bullets fade in one at a time. Drop your image into the frame.</a:t>
+              <a:t>CONTENT (image right). Bullets fade in one at a time.</a:t>
             </a:r>
             <a:endParaRPr lang="en-US" dirty="0"/>
           </a:p>
@@ -862,7 +862,7 @@
           <a:p>
             <a:r>
               <a:rPr lang="en-US" dirty="0"/>
-              <a:t>CONTENT SLIDE (image left). Alternate layout so the deck doesn't feel repetitive.</a:t>
+              <a:t>CONTENT (image left). Alternate layout.</a:t>
             </a:r>
             <a:endParaRPr lang="en-US" dirty="0"/>
           </a:p>
@@ -950,7 +950,7 @@
           <a:p>
             <a:r>
               <a:rPr lang="en-US" dirty="0"/>
-              <a:t>VIDEO / DEMO SLIDE. Insert &gt; Video into the frame, or run a live demo with a recorded fallback.</a:t>
+              <a:t>VIDEO / DEMO. Insert &gt; Video, or run a live demo with a recorded fallback.</a:t>
             </a:r>
             <a:endParaRPr lang="en-US" dirty="0"/>
           </a:p>
@@ -1038,7 +1038,7 @@
           <a:p>
             <a:r>
               <a:rPr lang="en-US" dirty="0"/>
-              <a:t>CONTENT SLIDE (full-width bullets), e.g. key takeaways or a recap. Bullets fade in on click.</a:t>
+              <a:t>CONTENT (full-width bullets), e.g. recap. Bullets fade in on click.</a:t>
             </a:r>
             <a:endParaRPr lang="en-US" dirty="0"/>
           </a:p>
@@ -1126,7 +1126,7 @@
           <a:p>
             <a:r>
               <a:rPr lang="en-US" dirty="0"/>
-              <a:t>THANK YOU SLIDE. Replace the closing line. Contact stays fixed.</a:t>
+              <a:t>THANK YOU. Replace the closing line. (Email + phone are on the final Q&amp;A slide.)</a:t>
             </a:r>
             <a:endParaRPr lang="en-US" dirty="0"/>
           </a:p>
@@ -1214,7 +1214,7 @@
           <a:p>
             <a:r>
               <a:rPr lang="en-US" dirty="0"/>
-              <a:t>Q&amp;A SLIDE. Keep contact + where to find the slides on screen.</a:t>
+              <a:t>Q&amp;A — the last page. Email + phone shown for direct follow-up.</a:t>
             </a:r>
             <a:endParaRPr lang="en-US" dirty="0"/>
           </a:p>
@@ -1595,7 +1595,46 @@
         </p:nvSpPr>
         <p:spPr>
           <a:xfrm>
-            <a:off x="841248" y="777240"/>
+            <a:off x="822960" y="6419088"/>
+            <a:ext cx="5486400" cy="292608"/>
+          </a:xfrm>
+          <a:prstGeom prst="rect">
+            <a:avLst/>
+          </a:prstGeom>
+          <a:noFill/>
+          <a:ln/>
+        </p:spPr>
+        <p:txBody>
+          <a:bodyPr wrap="square" rtlCol="0" anchor="ctr"/>
+          <a:lstStyle/>
+          <a:p>
+            <a:pPr indent="0" marL="0">
+              <a:buNone/>
+            </a:pPr>
+            <a:r>
+              <a:rPr lang="en-US" sz="1100" spc="100" kern="0" dirty="0">
+                <a:solidFill>
+                  <a:srgbClr val="AAB4C0"/>
+                </a:solidFill>
+                <a:latin typeface="Calibri" pitchFamily="34" charset="0"/>
+                <a:ea typeface="Calibri" pitchFamily="34" charset="-122"/>
+                <a:cs typeface="Calibri" pitchFamily="34" charset="-120"/>
+              </a:rPr>
+              <a:t>arjunthakur.dev</a:t>
+            </a:r>
+            <a:endParaRPr lang="en-US" sz="1100" dirty="0"/>
+          </a:p>
+        </p:txBody>
+      </p:sp>
+      <p:sp>
+        <p:nvSpPr>
+          <p:cNvPr id="3" name="Text 1"/>
+          <p:cNvSpPr/>
+          <p:nvPr/>
+        </p:nvSpPr>
+        <p:spPr>
+          <a:xfrm>
+            <a:off x="841248" y="731520"/>
             <a:ext cx="9144000" cy="365760"/>
           </a:xfrm>
           <a:prstGeom prst="rect">
@@ -1628,13 +1667,13 @@
       </p:sp>
       <p:sp>
         <p:nvSpPr>
-          <p:cNvPr id="3" name="Text 1"/>
-          <p:cNvSpPr/>
-          <p:nvPr/>
-        </p:nvSpPr>
-        <p:spPr>
-          <a:xfrm>
-            <a:off x="804672" y="1417320"/>
+          <p:cNvPr id="4" name="Text 2"/>
+          <p:cNvSpPr/>
+          <p:nvPr/>
+        </p:nvSpPr>
+        <p:spPr>
+          <a:xfrm>
+            <a:off x="804672" y="1280160"/>
             <a:ext cx="10698480" cy="1371600"/>
           </a:xfrm>
           <a:prstGeom prst="rect">
@@ -1681,13 +1720,13 @@
       </p:sp>
       <p:sp>
         <p:nvSpPr>
-          <p:cNvPr id="4" name="Text 2"/>
-          <p:cNvSpPr/>
-          <p:nvPr/>
-        </p:nvSpPr>
-        <p:spPr>
-          <a:xfrm>
-            <a:off x="859536" y="2788920"/>
+          <p:cNvPr id="5" name="Text 3"/>
+          <p:cNvSpPr/>
+          <p:nvPr/>
+        </p:nvSpPr>
+        <p:spPr>
+          <a:xfrm>
+            <a:off x="859536" y="2651760"/>
             <a:ext cx="10058400" cy="457200"/>
           </a:xfrm>
           <a:prstGeom prst="rect">
@@ -1720,13 +1759,13 @@
       </p:sp>
       <p:sp>
         <p:nvSpPr>
-          <p:cNvPr id="5" name="Text 3"/>
-          <p:cNvSpPr/>
-          <p:nvPr/>
-        </p:nvSpPr>
-        <p:spPr>
-          <a:xfrm>
-            <a:off x="841248" y="3931920"/>
+          <p:cNvPr id="6" name="Text 4"/>
+          <p:cNvSpPr/>
+          <p:nvPr/>
+        </p:nvSpPr>
+        <p:spPr>
+          <a:xfrm>
+            <a:off x="841248" y="3703320"/>
             <a:ext cx="10515600" cy="457200"/>
           </a:xfrm>
           <a:prstGeom prst="rect">
@@ -1773,13 +1812,13 @@
       </p:sp>
       <p:sp>
         <p:nvSpPr>
-          <p:cNvPr id="6" name="Text 4"/>
-          <p:cNvSpPr/>
-          <p:nvPr/>
-        </p:nvSpPr>
-        <p:spPr>
-          <a:xfrm>
-            <a:off x="859536" y="4480560"/>
+          <p:cNvPr id="7" name="Text 5"/>
+          <p:cNvSpPr/>
+          <p:nvPr/>
+        </p:nvSpPr>
+        <p:spPr>
+          <a:xfrm>
+            <a:off x="859536" y="4251960"/>
             <a:ext cx="10515600" cy="365760"/>
           </a:xfrm>
           <a:prstGeom prst="rect">
@@ -1812,13 +1851,13 @@
       </p:sp>
       <p:sp>
         <p:nvSpPr>
-          <p:cNvPr id="7" name="Shape 5"/>
-          <p:cNvSpPr/>
-          <p:nvPr/>
-        </p:nvSpPr>
-        <p:spPr>
-          <a:xfrm>
-            <a:off x="822960" y="5532120"/>
+          <p:cNvPr id="8" name="Shape 6"/>
+          <p:cNvSpPr/>
+          <p:nvPr/>
+        </p:nvSpPr>
+        <p:spPr>
+          <a:xfrm>
+            <a:off x="822960" y="5120640"/>
             <a:ext cx="3566160" cy="868680"/>
           </a:xfrm>
           <a:prstGeom prst="roundRect">
@@ -1839,13 +1878,13 @@
       </p:sp>
       <p:sp>
         <p:nvSpPr>
-          <p:cNvPr id="8" name="Text 6"/>
-          <p:cNvSpPr/>
-          <p:nvPr/>
-        </p:nvSpPr>
-        <p:spPr>
-          <a:xfrm>
-            <a:off x="950976" y="5550408"/>
+          <p:cNvPr id="9" name="Text 7"/>
+          <p:cNvSpPr/>
+          <p:nvPr/>
+        </p:nvSpPr>
+        <p:spPr>
+          <a:xfrm>
+            <a:off x="950976" y="5138928"/>
             <a:ext cx="640080" cy="822960"/>
           </a:xfrm>
           <a:prstGeom prst="rect">
@@ -1878,13 +1917,13 @@
       </p:sp>
       <p:sp>
         <p:nvSpPr>
-          <p:cNvPr id="9" name="Text 7"/>
-          <p:cNvSpPr/>
-          <p:nvPr/>
-        </p:nvSpPr>
-        <p:spPr>
-          <a:xfrm>
-            <a:off x="1572768" y="5678424"/>
+          <p:cNvPr id="10" name="Text 8"/>
+          <p:cNvSpPr/>
+          <p:nvPr/>
+        </p:nvSpPr>
+        <p:spPr>
+          <a:xfrm>
+            <a:off x="1572768" y="5266944"/>
             <a:ext cx="2697480" cy="274320"/>
           </a:xfrm>
           <a:prstGeom prst="rect">
@@ -1917,13 +1956,13 @@
       </p:sp>
       <p:sp>
         <p:nvSpPr>
-          <p:cNvPr id="10" name="Text 8"/>
-          <p:cNvSpPr/>
-          <p:nvPr/>
-        </p:nvSpPr>
-        <p:spPr>
-          <a:xfrm>
-            <a:off x="1572768" y="5934456"/>
+          <p:cNvPr id="11" name="Text 9"/>
+          <p:cNvSpPr/>
+          <p:nvPr/>
+        </p:nvSpPr>
+        <p:spPr>
+          <a:xfrm>
+            <a:off x="1572768" y="5522976"/>
             <a:ext cx="2697480" cy="320040"/>
           </a:xfrm>
           <a:prstGeom prst="rect">
@@ -1956,13 +1995,13 @@
       </p:sp>
       <p:sp>
         <p:nvSpPr>
-          <p:cNvPr id="11" name="Shape 9"/>
-          <p:cNvSpPr/>
-          <p:nvPr/>
-        </p:nvSpPr>
-        <p:spPr>
-          <a:xfrm>
-            <a:off x="4517136" y="5532120"/>
+          <p:cNvPr id="12" name="Shape 10"/>
+          <p:cNvSpPr/>
+          <p:nvPr/>
+        </p:nvSpPr>
+        <p:spPr>
+          <a:xfrm>
+            <a:off x="4517136" y="5120640"/>
             <a:ext cx="3063240" cy="868680"/>
           </a:xfrm>
           <a:prstGeom prst="roundRect">
@@ -1983,13 +2022,13 @@
       </p:sp>
       <p:sp>
         <p:nvSpPr>
-          <p:cNvPr id="12" name="Text 10"/>
-          <p:cNvSpPr/>
-          <p:nvPr/>
-        </p:nvSpPr>
-        <p:spPr>
-          <a:xfrm>
-            <a:off x="4645152" y="5550408"/>
+          <p:cNvPr id="13" name="Text 11"/>
+          <p:cNvSpPr/>
+          <p:nvPr/>
+        </p:nvSpPr>
+        <p:spPr>
+          <a:xfrm>
+            <a:off x="4645152" y="5138928"/>
             <a:ext cx="640080" cy="822960"/>
           </a:xfrm>
           <a:prstGeom prst="rect">
@@ -2014,7 +2053,7 @@
                 <a:ea typeface="Calibri" pitchFamily="34" charset="-122"/>
                 <a:cs typeface="Calibri" pitchFamily="34" charset="-120"/>
               </a:rPr>
-              <a:t>◉</a:t>
+              <a:t>☎</a:t>
             </a:r>
             <a:endParaRPr lang="en-US" sz="2000" dirty="0"/>
           </a:p>
@@ -2022,13 +2061,13 @@
       </p:sp>
       <p:sp>
         <p:nvSpPr>
-          <p:cNvPr id="13" name="Text 11"/>
-          <p:cNvSpPr/>
-          <p:nvPr/>
-        </p:nvSpPr>
-        <p:spPr>
-          <a:xfrm>
-            <a:off x="5266944" y="5678424"/>
+          <p:cNvPr id="14" name="Text 12"/>
+          <p:cNvSpPr/>
+          <p:nvPr/>
+        </p:nvSpPr>
+        <p:spPr>
+          <a:xfrm>
+            <a:off x="5266944" y="5266944"/>
             <a:ext cx="2194560" cy="274320"/>
           </a:xfrm>
           <a:prstGeom prst="rect">
@@ -2053,7 +2092,7 @@
                 <a:ea typeface="Calibri" pitchFamily="34" charset="-122"/>
                 <a:cs typeface="Calibri" pitchFamily="34" charset="-120"/>
               </a:rPr>
-              <a:t>WEBSITE</a:t>
+              <a:t>PHONE</a:t>
             </a:r>
             <a:endParaRPr lang="en-US" sz="1050" dirty="0"/>
           </a:p>
@@ -2061,13 +2100,13 @@
       </p:sp>
       <p:sp>
         <p:nvSpPr>
-          <p:cNvPr id="14" name="Text 12"/>
-          <p:cNvSpPr/>
-          <p:nvPr/>
-        </p:nvSpPr>
-        <p:spPr>
-          <a:xfrm>
-            <a:off x="5266944" y="5934456"/>
+          <p:cNvPr id="15" name="Text 13"/>
+          <p:cNvSpPr/>
+          <p:nvPr/>
+        </p:nvSpPr>
+        <p:spPr>
+          <a:xfrm>
+            <a:off x="5266944" y="5522976"/>
             <a:ext cx="2194560" cy="320040"/>
           </a:xfrm>
           <a:prstGeom prst="rect">
@@ -2092,7 +2131,7 @@
                 <a:ea typeface="Calibri" pitchFamily="34" charset="-122"/>
                 <a:cs typeface="Calibri" pitchFamily="34" charset="-120"/>
               </a:rPr>
-              <a:t>arjunthakur.dev</a:t>
+              <a:t>+91 93401 58116</a:t>
             </a:r>
             <a:endParaRPr lang="en-US" sz="1300" dirty="0"/>
           </a:p>
@@ -2100,13 +2139,13 @@
       </p:sp>
       <p:sp>
         <p:nvSpPr>
-          <p:cNvPr id="15" name="Shape 13"/>
-          <p:cNvSpPr/>
-          <p:nvPr/>
-        </p:nvSpPr>
-        <p:spPr>
-          <a:xfrm>
-            <a:off x="7708392" y="5532120"/>
+          <p:cNvPr id="16" name="Shape 14"/>
+          <p:cNvSpPr/>
+          <p:nvPr/>
+        </p:nvSpPr>
+        <p:spPr>
+          <a:xfrm>
+            <a:off x="7708392" y="5120640"/>
             <a:ext cx="3657600" cy="868680"/>
           </a:xfrm>
           <a:prstGeom prst="roundRect">
@@ -2127,13 +2166,13 @@
       </p:sp>
       <p:sp>
         <p:nvSpPr>
-          <p:cNvPr id="16" name="Text 14"/>
-          <p:cNvSpPr/>
-          <p:nvPr/>
-        </p:nvSpPr>
-        <p:spPr>
-          <a:xfrm>
-            <a:off x="7836408" y="5550408"/>
+          <p:cNvPr id="17" name="Text 15"/>
+          <p:cNvSpPr/>
+          <p:nvPr/>
+        </p:nvSpPr>
+        <p:spPr>
+          <a:xfrm>
+            <a:off x="7836408" y="5138928"/>
             <a:ext cx="640080" cy="822960"/>
           </a:xfrm>
           <a:prstGeom prst="rect">
@@ -2158,7 +2197,7 @@
                 <a:ea typeface="Calibri" pitchFamily="34" charset="-122"/>
                 <a:cs typeface="Calibri" pitchFamily="34" charset="-120"/>
               </a:rPr>
-              <a:t>■</a:t>
+              <a:t>◉</a:t>
             </a:r>
             <a:endParaRPr lang="en-US" sz="2000" dirty="0"/>
           </a:p>
@@ -2166,13 +2205,13 @@
       </p:sp>
       <p:sp>
         <p:nvSpPr>
-          <p:cNvPr id="17" name="Text 15"/>
-          <p:cNvSpPr/>
-          <p:nvPr/>
-        </p:nvSpPr>
-        <p:spPr>
-          <a:xfrm>
-            <a:off x="8458200" y="5678424"/>
+          <p:cNvPr id="18" name="Text 16"/>
+          <p:cNvSpPr/>
+          <p:nvPr/>
+        </p:nvSpPr>
+        <p:spPr>
+          <a:xfrm>
+            <a:off x="8458200" y="5266944"/>
             <a:ext cx="2788920" cy="274320"/>
           </a:xfrm>
           <a:prstGeom prst="rect">
@@ -2197,7 +2236,7 @@
                 <a:ea typeface="Calibri" pitchFamily="34" charset="-122"/>
                 <a:cs typeface="Calibri" pitchFamily="34" charset="-120"/>
               </a:rPr>
-              <a:t>LINKEDIN</a:t>
+              <a:t>WEBSITE</a:t>
             </a:r>
             <a:endParaRPr lang="en-US" sz="1050" dirty="0"/>
           </a:p>
@@ -2205,13 +2244,13 @@
       </p:sp>
       <p:sp>
         <p:nvSpPr>
-          <p:cNvPr id="18" name="Text 16"/>
-          <p:cNvSpPr/>
-          <p:nvPr/>
-        </p:nvSpPr>
-        <p:spPr>
-          <a:xfrm>
-            <a:off x="8458200" y="5934456"/>
+          <p:cNvPr id="19" name="Text 17"/>
+          <p:cNvSpPr/>
+          <p:nvPr/>
+        </p:nvSpPr>
+        <p:spPr>
+          <a:xfrm>
+            <a:off x="8458200" y="5522976"/>
             <a:ext cx="2788920" cy="320040"/>
           </a:xfrm>
           <a:prstGeom prst="rect">
@@ -2230,13 +2269,13 @@
             <a:r>
               <a:rPr lang="en-US" sz="1300" dirty="0">
                 <a:solidFill>
-                  <a:srgbClr val="E6EDF3"/>
-                </a:solidFill>
-                <a:latin typeface="Calibri" pitchFamily="34" charset="0"/>
-                <a:ea typeface="Calibri" pitchFamily="34" charset="-122"/>
-                <a:cs typeface="Calibri" pitchFamily="34" charset="-120"/>
-              </a:rPr>
-              <a:t>in/thakurarjun247</a:t>
+                  <a:srgbClr val="22D3EE"/>
+                </a:solidFill>
+                <a:latin typeface="Calibri" pitchFamily="34" charset="0"/>
+                <a:ea typeface="Calibri" pitchFamily="34" charset="-122"/>
+                <a:cs typeface="Calibri" pitchFamily="34" charset="-120"/>
+              </a:rPr>
+              <a:t>arjunthakur.dev</a:t>
             </a:r>
             <a:endParaRPr lang="en-US" sz="1300" dirty="0"/>
           </a:p>
@@ -2282,6 +2321,45 @@
         </p:nvSpPr>
         <p:spPr>
           <a:xfrm>
+            <a:off x="822960" y="6419088"/>
+            <a:ext cx="5486400" cy="292608"/>
+          </a:xfrm>
+          <a:prstGeom prst="rect">
+            <a:avLst/>
+          </a:prstGeom>
+          <a:noFill/>
+          <a:ln/>
+        </p:spPr>
+        <p:txBody>
+          <a:bodyPr wrap="square" rtlCol="0" anchor="ctr"/>
+          <a:lstStyle/>
+          <a:p>
+            <a:pPr indent="0" marL="0">
+              <a:buNone/>
+            </a:pPr>
+            <a:r>
+              <a:rPr lang="en-US" sz="1100" spc="100" kern="0" dirty="0">
+                <a:solidFill>
+                  <a:srgbClr val="AAB4C0"/>
+                </a:solidFill>
+                <a:latin typeface="Calibri" pitchFamily="34" charset="0"/>
+                <a:ea typeface="Calibri" pitchFamily="34" charset="-122"/>
+                <a:cs typeface="Calibri" pitchFamily="34" charset="-120"/>
+              </a:rPr>
+              <a:t>arjunthakur.dev</a:t>
+            </a:r>
+            <a:endParaRPr lang="en-US" sz="1100" dirty="0"/>
+          </a:p>
+        </p:txBody>
+      </p:sp>
+      <p:sp>
+        <p:nvSpPr>
+          <p:cNvPr id="3" name="Text 1"/>
+          <p:cNvSpPr/>
+          <p:nvPr/>
+        </p:nvSpPr>
+        <p:spPr>
+          <a:xfrm>
             <a:off x="822960" y="640080"/>
             <a:ext cx="7315200" cy="731520"/>
           </a:xfrm>
@@ -2315,14 +2393,14 @@
       </p:sp>
       <p:sp>
         <p:nvSpPr>
-          <p:cNvPr id="3" name="animList"/>
+          <p:cNvPr id="4" name="animList"/>
           <p:cNvSpPr/>
           <p:nvPr/>
         </p:nvSpPr>
         <p:spPr>
           <a:xfrm>
             <a:off x="822960" y="1783080"/>
-            <a:ext cx="6766560" cy="4023360"/>
+            <a:ext cx="6766560" cy="3840480"/>
           </a:xfrm>
           <a:prstGeom prst="rect">
             <a:avLst/>
@@ -2473,14 +2551,14 @@
       </p:sp>
       <p:sp>
         <p:nvSpPr>
-          <p:cNvPr id="4" name="Shape 2"/>
+          <p:cNvPr id="5" name="Shape 3"/>
           <p:cNvSpPr/>
           <p:nvPr/>
         </p:nvSpPr>
         <p:spPr>
           <a:xfrm>
             <a:off x="8138160" y="1783080"/>
-            <a:ext cx="3200400" cy="3977640"/>
+            <a:ext cx="3200400" cy="3840480"/>
           </a:xfrm>
           <a:prstGeom prst="roundRect">
             <a:avLst>
@@ -2500,13 +2578,13 @@
       </p:sp>
       <p:sp>
         <p:nvSpPr>
-          <p:cNvPr id="5" name="Text 3"/>
-          <p:cNvSpPr/>
-          <p:nvPr/>
-        </p:nvSpPr>
-        <p:spPr>
-          <a:xfrm>
-            <a:off x="8138160" y="2286000"/>
+          <p:cNvPr id="6" name="Text 4"/>
+          <p:cNvSpPr/>
+          <p:nvPr/>
+        </p:nvSpPr>
+        <p:spPr>
+          <a:xfrm>
+            <a:off x="8138160" y="2240280"/>
             <a:ext cx="3200400" cy="1280160"/>
           </a:xfrm>
           <a:prstGeom prst="rect">
@@ -2539,13 +2617,13 @@
       </p:sp>
       <p:sp>
         <p:nvSpPr>
-          <p:cNvPr id="6" name="Text 4"/>
-          <p:cNvSpPr/>
-          <p:nvPr/>
-        </p:nvSpPr>
-        <p:spPr>
-          <a:xfrm>
-            <a:off x="8138160" y="3657600"/>
+          <p:cNvPr id="7" name="Text 5"/>
+          <p:cNvSpPr/>
+          <p:nvPr/>
+        </p:nvSpPr>
+        <p:spPr>
+          <a:xfrm>
+            <a:off x="8138160" y="3611880"/>
             <a:ext cx="3200400" cy="457200"/>
           </a:xfrm>
           <a:prstGeom prst="rect">
@@ -2615,7 +2693,7 @@
                                           </p:stCondLst>
                                         </p:cTn>
                                         <p:tgtEl>
-                                          <p:spTgt spid="3">
+                                          <p:spTgt spid="4">
                                             <p:txEl>
                                               <p:pRg st="0" end="0"/>
                                             </p:txEl>
@@ -2633,7 +2711,7 @@
                                       <p:cBhvr>
                                         <p:cTn id="7" dur="500"/>
                                         <p:tgtEl>
-                                          <p:spTgt spid="3">
+                                          <p:spTgt spid="4">
                                             <p:txEl>
                                               <p:pRg st="0" end="0"/>
                                             </p:txEl>
@@ -2676,7 +2754,7 @@
                                           </p:stCondLst>
                                         </p:cTn>
                                         <p:tgtEl>
-                                          <p:spTgt spid="3">
+                                          <p:spTgt spid="4">
                                             <p:txEl>
                                               <p:pRg st="1" end="1"/>
                                             </p:txEl>
@@ -2694,7 +2772,7 @@
                                       <p:cBhvr>
                                         <p:cTn id="12" dur="500"/>
                                         <p:tgtEl>
-                                          <p:spTgt spid="3">
+                                          <p:spTgt spid="4">
                                             <p:txEl>
                                               <p:pRg st="1" end="1"/>
                                             </p:txEl>
@@ -2737,7 +2815,7 @@
                                           </p:stCondLst>
                                         </p:cTn>
                                         <p:tgtEl>
-                                          <p:spTgt spid="3">
+                                          <p:spTgt spid="4">
                                             <p:txEl>
                                               <p:pRg st="2" end="2"/>
                                             </p:txEl>
@@ -2755,7 +2833,7 @@
                                       <p:cBhvr>
                                         <p:cTn id="17" dur="500"/>
                                         <p:tgtEl>
-                                          <p:spTgt spid="3">
+                                          <p:spTgt spid="4">
                                             <p:txEl>
                                               <p:pRg st="2" end="2"/>
                                             </p:txEl>
@@ -2798,7 +2876,7 @@
                                           </p:stCondLst>
                                         </p:cTn>
                                         <p:tgtEl>
-                                          <p:spTgt spid="3">
+                                          <p:spTgt spid="4">
                                             <p:txEl>
                                               <p:pRg st="3" end="3"/>
                                             </p:txEl>
@@ -2816,7 +2894,7 @@
                                       <p:cBhvr>
                                         <p:cTn id="22" dur="500"/>
                                         <p:tgtEl>
-                                          <p:spTgt spid="3">
+                                          <p:spTgt spid="4">
                                             <p:txEl>
                                               <p:pRg st="3" end="3"/>
                                             </p:txEl>
@@ -2855,7 +2933,7 @@
       </p:par>
     </p:tnLst>
     <p:bldLst>
-      <p:bldP spid="3" grpId="0" build="p"/>
+      <p:bldP spid="4" grpId="0" build="p"/>
     </p:bldLst>
   </p:timing>
 </p:sld>
@@ -2893,7 +2971,46 @@
         </p:nvSpPr>
         <p:spPr>
           <a:xfrm>
-            <a:off x="749808" y="502920"/>
+            <a:off x="822960" y="6419088"/>
+            <a:ext cx="5486400" cy="292608"/>
+          </a:xfrm>
+          <a:prstGeom prst="rect">
+            <a:avLst/>
+          </a:prstGeom>
+          <a:noFill/>
+          <a:ln/>
+        </p:spPr>
+        <p:txBody>
+          <a:bodyPr wrap="square" rtlCol="0" anchor="ctr"/>
+          <a:lstStyle/>
+          <a:p>
+            <a:pPr indent="0" marL="0">
+              <a:buNone/>
+            </a:pPr>
+            <a:r>
+              <a:rPr lang="en-US" sz="1100" spc="100" kern="0" dirty="0">
+                <a:solidFill>
+                  <a:srgbClr val="AAB4C0"/>
+                </a:solidFill>
+                <a:latin typeface="Calibri" pitchFamily="34" charset="0"/>
+                <a:ea typeface="Calibri" pitchFamily="34" charset="-122"/>
+                <a:cs typeface="Calibri" pitchFamily="34" charset="-120"/>
+              </a:rPr>
+              <a:t>arjunthakur.dev</a:t>
+            </a:r>
+            <a:endParaRPr lang="en-US" sz="1100" dirty="0"/>
+          </a:p>
+        </p:txBody>
+      </p:sp>
+      <p:sp>
+        <p:nvSpPr>
+          <p:cNvPr id="3" name="Text 1"/>
+          <p:cNvSpPr/>
+          <p:nvPr/>
+        </p:nvSpPr>
+        <p:spPr>
+          <a:xfrm>
+            <a:off x="749808" y="457200"/>
             <a:ext cx="4572000" cy="2377440"/>
           </a:xfrm>
           <a:prstGeom prst="rect">
@@ -2926,13 +3043,13 @@
       </p:sp>
       <p:sp>
         <p:nvSpPr>
-          <p:cNvPr id="3" name="Text 1"/>
-          <p:cNvSpPr/>
-          <p:nvPr/>
-        </p:nvSpPr>
-        <p:spPr>
-          <a:xfrm>
-            <a:off x="868680" y="3246120"/>
+          <p:cNvPr id="4" name="Text 2"/>
+          <p:cNvSpPr/>
+          <p:nvPr/>
+        </p:nvSpPr>
+        <p:spPr>
+          <a:xfrm>
+            <a:off x="868680" y="3200400"/>
             <a:ext cx="9144000" cy="365760"/>
           </a:xfrm>
           <a:prstGeom prst="rect">
@@ -2965,13 +3082,13 @@
       </p:sp>
       <p:sp>
         <p:nvSpPr>
-          <p:cNvPr id="4" name="Text 2"/>
-          <p:cNvSpPr/>
-          <p:nvPr/>
-        </p:nvSpPr>
-        <p:spPr>
-          <a:xfrm>
-            <a:off x="822960" y="3611880"/>
+          <p:cNvPr id="5" name="Text 3"/>
+          <p:cNvSpPr/>
+          <p:nvPr/>
+        </p:nvSpPr>
+        <p:spPr>
+          <a:xfrm>
+            <a:off x="822960" y="3566160"/>
             <a:ext cx="10515600" cy="1005840"/>
           </a:xfrm>
           <a:prstGeom prst="rect">
@@ -3004,13 +3121,13 @@
       </p:sp>
       <p:sp>
         <p:nvSpPr>
-          <p:cNvPr id="5" name="Text 3"/>
-          <p:cNvSpPr/>
-          <p:nvPr/>
-        </p:nvSpPr>
-        <p:spPr>
-          <a:xfrm>
-            <a:off x="859536" y="4663440"/>
+          <p:cNvPr id="6" name="Text 4"/>
+          <p:cNvSpPr/>
+          <p:nvPr/>
+        </p:nvSpPr>
+        <p:spPr>
+          <a:xfrm>
+            <a:off x="859536" y="4617720"/>
             <a:ext cx="10058400" cy="457200"/>
           </a:xfrm>
           <a:prstGeom prst="rect">
@@ -3081,6 +3198,45 @@
         </p:nvSpPr>
         <p:spPr>
           <a:xfrm>
+            <a:off x="822960" y="6419088"/>
+            <a:ext cx="5486400" cy="292608"/>
+          </a:xfrm>
+          <a:prstGeom prst="rect">
+            <a:avLst/>
+          </a:prstGeom>
+          <a:noFill/>
+          <a:ln/>
+        </p:spPr>
+        <p:txBody>
+          <a:bodyPr wrap="square" rtlCol="0" anchor="ctr"/>
+          <a:lstStyle/>
+          <a:p>
+            <a:pPr indent="0" marL="0">
+              <a:buNone/>
+            </a:pPr>
+            <a:r>
+              <a:rPr lang="en-US" sz="1100" spc="100" kern="0" dirty="0">
+                <a:solidFill>
+                  <a:srgbClr val="AAB4C0"/>
+                </a:solidFill>
+                <a:latin typeface="Calibri" pitchFamily="34" charset="0"/>
+                <a:ea typeface="Calibri" pitchFamily="34" charset="-122"/>
+                <a:cs typeface="Calibri" pitchFamily="34" charset="-120"/>
+              </a:rPr>
+              <a:t>arjunthakur.dev</a:t>
+            </a:r>
+            <a:endParaRPr lang="en-US" sz="1100" dirty="0"/>
+          </a:p>
+        </p:txBody>
+      </p:sp>
+      <p:sp>
+        <p:nvSpPr>
+          <p:cNvPr id="3" name="Text 1"/>
+          <p:cNvSpPr/>
+          <p:nvPr/>
+        </p:nvSpPr>
+        <p:spPr>
+          <a:xfrm>
             <a:off x="822960" y="640080"/>
             <a:ext cx="10515600" cy="731520"/>
           </a:xfrm>
@@ -3114,14 +3270,14 @@
       </p:sp>
       <p:sp>
         <p:nvSpPr>
-          <p:cNvPr id="3" name="animList"/>
+          <p:cNvPr id="4" name="animList"/>
           <p:cNvSpPr/>
           <p:nvPr/>
         </p:nvSpPr>
         <p:spPr>
           <a:xfrm>
             <a:off x="822960" y="1828800"/>
-            <a:ext cx="5852160" cy="4023360"/>
+            <a:ext cx="5852160" cy="3840480"/>
           </a:xfrm>
           <a:prstGeom prst="rect">
             <a:avLst/>
@@ -3272,18 +3428,18 @@
       </p:sp>
       <p:sp>
         <p:nvSpPr>
-          <p:cNvPr id="4" name="Shape 2"/>
+          <p:cNvPr id="5" name="Shape 3"/>
           <p:cNvSpPr/>
           <p:nvPr/>
         </p:nvSpPr>
         <p:spPr>
           <a:xfrm>
             <a:off x="7040880" y="1783080"/>
-            <a:ext cx="4297680" cy="4114800"/>
+            <a:ext cx="4297680" cy="3931920"/>
           </a:xfrm>
           <a:prstGeom prst="roundRect">
             <a:avLst>
-              <a:gd name="adj" fmla="val 2222"/>
+              <a:gd name="adj" fmla="val 2326"/>
             </a:avLst>
           </a:prstGeom>
           <a:solidFill>
@@ -3299,13 +3455,13 @@
       </p:sp>
       <p:sp>
         <p:nvSpPr>
-          <p:cNvPr id="5" name="Shape 3"/>
-          <p:cNvSpPr/>
-          <p:nvPr/>
-        </p:nvSpPr>
-        <p:spPr>
-          <a:xfrm>
-            <a:off x="8275320" y="2971800"/>
+          <p:cNvPr id="6" name="Shape 4"/>
+          <p:cNvSpPr/>
+          <p:nvPr/>
+        </p:nvSpPr>
+        <p:spPr>
+          <a:xfrm>
+            <a:off x="8275320" y="2880360"/>
             <a:ext cx="457200" cy="457200"/>
           </a:xfrm>
           <a:prstGeom prst="ellipse">
@@ -3319,13 +3475,13 @@
       </p:sp>
       <p:sp>
         <p:nvSpPr>
-          <p:cNvPr id="6" name="Shape 4"/>
-          <p:cNvSpPr/>
-          <p:nvPr/>
-        </p:nvSpPr>
-        <p:spPr>
-          <a:xfrm>
-            <a:off x="8183880" y="3520440"/>
+          <p:cNvPr id="7" name="Shape 5"/>
+          <p:cNvSpPr/>
+          <p:nvPr/>
+        </p:nvSpPr>
+        <p:spPr>
+          <a:xfrm>
+            <a:off x="8183880" y="3429000"/>
             <a:ext cx="1188720" cy="777240"/>
           </a:xfrm>
           <a:prstGeom prst="triangle">
@@ -3339,13 +3495,13 @@
       </p:sp>
       <p:sp>
         <p:nvSpPr>
-          <p:cNvPr id="7" name="Shape 5"/>
-          <p:cNvSpPr/>
-          <p:nvPr/>
-        </p:nvSpPr>
-        <p:spPr>
-          <a:xfrm>
-            <a:off x="9098280" y="3337560"/>
+          <p:cNvPr id="8" name="Shape 6"/>
+          <p:cNvSpPr/>
+          <p:nvPr/>
+        </p:nvSpPr>
+        <p:spPr>
+          <a:xfrm>
+            <a:off x="9098280" y="3246120"/>
             <a:ext cx="1280160" cy="960120"/>
           </a:xfrm>
           <a:prstGeom prst="triangle">
@@ -3359,13 +3515,13 @@
       </p:sp>
       <p:sp>
         <p:nvSpPr>
-          <p:cNvPr id="8" name="Text 6"/>
-          <p:cNvSpPr/>
-          <p:nvPr/>
-        </p:nvSpPr>
-        <p:spPr>
-          <a:xfrm>
-            <a:off x="7223760" y="5212080"/>
+          <p:cNvPr id="9" name="Text 7"/>
+          <p:cNvSpPr/>
+          <p:nvPr/>
+        </p:nvSpPr>
+        <p:spPr>
+          <a:xfrm>
+            <a:off x="7223760" y="5029200"/>
             <a:ext cx="3931920" cy="457200"/>
           </a:xfrm>
           <a:prstGeom prst="rect">
@@ -3435,7 +3591,7 @@
                                           </p:stCondLst>
                                         </p:cTn>
                                         <p:tgtEl>
-                                          <p:spTgt spid="3">
+                                          <p:spTgt spid="4">
                                             <p:txEl>
                                               <p:pRg st="0" end="0"/>
                                             </p:txEl>
@@ -3453,7 +3609,7 @@
                                       <p:cBhvr>
                                         <p:cTn id="7" dur="500"/>
                                         <p:tgtEl>
-                                          <p:spTgt spid="3">
+                                          <p:spTgt spid="4">
                                             <p:txEl>
                                               <p:pRg st="0" end="0"/>
                                             </p:txEl>
@@ -3496,7 +3652,7 @@
                                           </p:stCondLst>
                                         </p:cTn>
                                         <p:tgtEl>
-                                          <p:spTgt spid="3">
+                                          <p:spTgt spid="4">
                                             <p:txEl>
                                               <p:pRg st="1" end="1"/>
                                             </p:txEl>
@@ -3514,7 +3670,7 @@
                                       <p:cBhvr>
                                         <p:cTn id="12" dur="500"/>
                                         <p:tgtEl>
-                                          <p:spTgt spid="3">
+                                          <p:spTgt spid="4">
                                             <p:txEl>
                                               <p:pRg st="1" end="1"/>
                                             </p:txEl>
@@ -3557,7 +3713,7 @@
                                           </p:stCondLst>
                                         </p:cTn>
                                         <p:tgtEl>
-                                          <p:spTgt spid="3">
+                                          <p:spTgt spid="4">
                                             <p:txEl>
                                               <p:pRg st="2" end="2"/>
                                             </p:txEl>
@@ -3575,7 +3731,7 @@
                                       <p:cBhvr>
                                         <p:cTn id="17" dur="500"/>
                                         <p:tgtEl>
-                                          <p:spTgt spid="3">
+                                          <p:spTgt spid="4">
                                             <p:txEl>
                                               <p:pRg st="2" end="2"/>
                                             </p:txEl>
@@ -3618,7 +3774,7 @@
                                           </p:stCondLst>
                                         </p:cTn>
                                         <p:tgtEl>
-                                          <p:spTgt spid="3">
+                                          <p:spTgt spid="4">
                                             <p:txEl>
                                               <p:pRg st="3" end="3"/>
                                             </p:txEl>
@@ -3636,7 +3792,7 @@
                                       <p:cBhvr>
                                         <p:cTn id="22" dur="500"/>
                                         <p:tgtEl>
-                                          <p:spTgt spid="3">
+                                          <p:spTgt spid="4">
                                             <p:txEl>
                                               <p:pRg st="3" end="3"/>
                                             </p:txEl>
@@ -3675,7 +3831,7 @@
       </p:par>
     </p:tnLst>
     <p:bldLst>
-      <p:bldP spid="3" grpId="0" build="p"/>
+      <p:bldP spid="4" grpId="0" build="p"/>
     </p:bldLst>
   </p:timing>
 </p:sld>
@@ -3713,6 +3869,45 @@
         </p:nvSpPr>
         <p:spPr>
           <a:xfrm>
+            <a:off x="822960" y="6419088"/>
+            <a:ext cx="5486400" cy="292608"/>
+          </a:xfrm>
+          <a:prstGeom prst="rect">
+            <a:avLst/>
+          </a:prstGeom>
+          <a:noFill/>
+          <a:ln/>
+        </p:spPr>
+        <p:txBody>
+          <a:bodyPr wrap="square" rtlCol="0" anchor="ctr"/>
+          <a:lstStyle/>
+          <a:p>
+            <a:pPr indent="0" marL="0">
+              <a:buNone/>
+            </a:pPr>
+            <a:r>
+              <a:rPr lang="en-US" sz="1100" spc="100" kern="0" dirty="0">
+                <a:solidFill>
+                  <a:srgbClr val="AAB4C0"/>
+                </a:solidFill>
+                <a:latin typeface="Calibri" pitchFamily="34" charset="0"/>
+                <a:ea typeface="Calibri" pitchFamily="34" charset="-122"/>
+                <a:cs typeface="Calibri" pitchFamily="34" charset="-120"/>
+              </a:rPr>
+              <a:t>arjunthakur.dev</a:t>
+            </a:r>
+            <a:endParaRPr lang="en-US" sz="1100" dirty="0"/>
+          </a:p>
+        </p:txBody>
+      </p:sp>
+      <p:sp>
+        <p:nvSpPr>
+          <p:cNvPr id="3" name="Text 1"/>
+          <p:cNvSpPr/>
+          <p:nvPr/>
+        </p:nvSpPr>
+        <p:spPr>
+          <a:xfrm>
             <a:off x="822960" y="640080"/>
             <a:ext cx="10515600" cy="731520"/>
           </a:xfrm>
@@ -3746,18 +3941,18 @@
       </p:sp>
       <p:sp>
         <p:nvSpPr>
-          <p:cNvPr id="3" name="Shape 1"/>
+          <p:cNvPr id="4" name="Shape 2"/>
           <p:cNvSpPr/>
           <p:nvPr/>
         </p:nvSpPr>
         <p:spPr>
           <a:xfrm>
             <a:off x="822960" y="1783080"/>
-            <a:ext cx="4297680" cy="4114800"/>
+            <a:ext cx="4297680" cy="3931920"/>
           </a:xfrm>
           <a:prstGeom prst="roundRect">
             <a:avLst>
-              <a:gd name="adj" fmla="val 2222"/>
+              <a:gd name="adj" fmla="val 2326"/>
             </a:avLst>
           </a:prstGeom>
           <a:solidFill>
@@ -3773,13 +3968,13 @@
       </p:sp>
       <p:sp>
         <p:nvSpPr>
-          <p:cNvPr id="4" name="Shape 2"/>
-          <p:cNvSpPr/>
-          <p:nvPr/>
-        </p:nvSpPr>
-        <p:spPr>
-          <a:xfrm>
-            <a:off x="2057400" y="2971800"/>
+          <p:cNvPr id="5" name="Shape 3"/>
+          <p:cNvSpPr/>
+          <p:nvPr/>
+        </p:nvSpPr>
+        <p:spPr>
+          <a:xfrm>
+            <a:off x="2057400" y="2880360"/>
             <a:ext cx="457200" cy="457200"/>
           </a:xfrm>
           <a:prstGeom prst="ellipse">
@@ -3793,13 +3988,13 @@
       </p:sp>
       <p:sp>
         <p:nvSpPr>
-          <p:cNvPr id="5" name="Shape 3"/>
-          <p:cNvSpPr/>
-          <p:nvPr/>
-        </p:nvSpPr>
-        <p:spPr>
-          <a:xfrm>
-            <a:off x="1965960" y="3520440"/>
+          <p:cNvPr id="6" name="Shape 4"/>
+          <p:cNvSpPr/>
+          <p:nvPr/>
+        </p:nvSpPr>
+        <p:spPr>
+          <a:xfrm>
+            <a:off x="1965960" y="3429000"/>
             <a:ext cx="1188720" cy="777240"/>
           </a:xfrm>
           <a:prstGeom prst="triangle">
@@ -3813,13 +4008,13 @@
       </p:sp>
       <p:sp>
         <p:nvSpPr>
-          <p:cNvPr id="6" name="Shape 4"/>
-          <p:cNvSpPr/>
-          <p:nvPr/>
-        </p:nvSpPr>
-        <p:spPr>
-          <a:xfrm>
-            <a:off x="2880360" y="3337560"/>
+          <p:cNvPr id="7" name="Shape 5"/>
+          <p:cNvSpPr/>
+          <p:nvPr/>
+        </p:nvSpPr>
+        <p:spPr>
+          <a:xfrm>
+            <a:off x="2880360" y="3246120"/>
             <a:ext cx="1280160" cy="960120"/>
           </a:xfrm>
           <a:prstGeom prst="triangle">
@@ -3833,13 +4028,13 @@
       </p:sp>
       <p:sp>
         <p:nvSpPr>
-          <p:cNvPr id="7" name="Text 5"/>
-          <p:cNvSpPr/>
-          <p:nvPr/>
-        </p:nvSpPr>
-        <p:spPr>
-          <a:xfrm>
-            <a:off x="1005840" y="5212080"/>
+          <p:cNvPr id="8" name="Text 6"/>
+          <p:cNvSpPr/>
+          <p:nvPr/>
+        </p:nvSpPr>
+        <p:spPr>
+          <a:xfrm>
+            <a:off x="1005840" y="5029200"/>
             <a:ext cx="3931920" cy="457200"/>
           </a:xfrm>
           <a:prstGeom prst="rect">
@@ -3872,14 +4067,14 @@
       </p:sp>
       <p:sp>
         <p:nvSpPr>
-          <p:cNvPr id="8" name="animList"/>
+          <p:cNvPr id="9" name="animList"/>
           <p:cNvSpPr/>
           <p:nvPr/>
         </p:nvSpPr>
         <p:spPr>
           <a:xfrm>
             <a:off x="5577840" y="1828800"/>
-            <a:ext cx="5760720" cy="4023360"/>
+            <a:ext cx="5760720" cy="3840480"/>
           </a:xfrm>
           <a:prstGeom prst="rect">
             <a:avLst/>
@@ -4033,7 +4228,7 @@
                                           </p:stCondLst>
                                         </p:cTn>
                                         <p:tgtEl>
-                                          <p:spTgt spid="8">
+                                          <p:spTgt spid="9">
                                             <p:txEl>
                                               <p:pRg st="0" end="0"/>
                                             </p:txEl>
@@ -4051,7 +4246,7 @@
                                       <p:cBhvr>
                                         <p:cTn id="7" dur="500"/>
                                         <p:tgtEl>
-                                          <p:spTgt spid="8">
+                                          <p:spTgt spid="9">
                                             <p:txEl>
                                               <p:pRg st="0" end="0"/>
                                             </p:txEl>
@@ -4094,7 +4289,7 @@
                                           </p:stCondLst>
                                         </p:cTn>
                                         <p:tgtEl>
-                                          <p:spTgt spid="8">
+                                          <p:spTgt spid="9">
                                             <p:txEl>
                                               <p:pRg st="1" end="1"/>
                                             </p:txEl>
@@ -4112,7 +4307,7 @@
                                       <p:cBhvr>
                                         <p:cTn id="12" dur="500"/>
                                         <p:tgtEl>
-                                          <p:spTgt spid="8">
+                                          <p:spTgt spid="9">
                                             <p:txEl>
                                               <p:pRg st="1" end="1"/>
                                             </p:txEl>
@@ -4155,7 +4350,7 @@
                                           </p:stCondLst>
                                         </p:cTn>
                                         <p:tgtEl>
-                                          <p:spTgt spid="8">
+                                          <p:spTgt spid="9">
                                             <p:txEl>
                                               <p:pRg st="2" end="2"/>
                                             </p:txEl>
@@ -4173,7 +4368,7 @@
                                       <p:cBhvr>
                                         <p:cTn id="17" dur="500"/>
                                         <p:tgtEl>
-                                          <p:spTgt spid="8">
+                                          <p:spTgt spid="9">
                                             <p:txEl>
                                               <p:pRg st="2" end="2"/>
                                             </p:txEl>
@@ -4212,7 +4407,7 @@
       </p:par>
     </p:tnLst>
     <p:bldLst>
-      <p:bldP spid="8" grpId="0" build="p"/>
+      <p:bldP spid="9" grpId="0" build="p"/>
     </p:bldLst>
   </p:timing>
 </p:sld>
@@ -4250,6 +4445,45 @@
         </p:nvSpPr>
         <p:spPr>
           <a:xfrm>
+            <a:off x="822960" y="6419088"/>
+            <a:ext cx="5486400" cy="292608"/>
+          </a:xfrm>
+          <a:prstGeom prst="rect">
+            <a:avLst/>
+          </a:prstGeom>
+          <a:noFill/>
+          <a:ln/>
+        </p:spPr>
+        <p:txBody>
+          <a:bodyPr wrap="square" rtlCol="0" anchor="ctr"/>
+          <a:lstStyle/>
+          <a:p>
+            <a:pPr indent="0" marL="0">
+              <a:buNone/>
+            </a:pPr>
+            <a:r>
+              <a:rPr lang="en-US" sz="1100" spc="100" kern="0" dirty="0">
+                <a:solidFill>
+                  <a:srgbClr val="AAB4C0"/>
+                </a:solidFill>
+                <a:latin typeface="Calibri" pitchFamily="34" charset="0"/>
+                <a:ea typeface="Calibri" pitchFamily="34" charset="-122"/>
+                <a:cs typeface="Calibri" pitchFamily="34" charset="-120"/>
+              </a:rPr>
+              <a:t>arjunthakur.dev</a:t>
+            </a:r>
+            <a:endParaRPr lang="en-US" sz="1100" dirty="0"/>
+          </a:p>
+        </p:txBody>
+      </p:sp>
+      <p:sp>
+        <p:nvSpPr>
+          <p:cNvPr id="3" name="Text 1"/>
+          <p:cNvSpPr/>
+          <p:nvPr/>
+        </p:nvSpPr>
+        <p:spPr>
+          <a:xfrm>
             <a:off x="822960" y="548640"/>
             <a:ext cx="10515600" cy="731520"/>
           </a:xfrm>
@@ -4283,18 +4517,18 @@
       </p:sp>
       <p:sp>
         <p:nvSpPr>
-          <p:cNvPr id="3" name="Shape 1"/>
-          <p:cNvSpPr/>
-          <p:nvPr/>
-        </p:nvSpPr>
-        <p:spPr>
-          <a:xfrm>
-            <a:off x="2514600" y="1554480"/>
-            <a:ext cx="7132320" cy="4023360"/>
+          <p:cNvPr id="4" name="Shape 2"/>
+          <p:cNvSpPr/>
+          <p:nvPr/>
+        </p:nvSpPr>
+        <p:spPr>
+          <a:xfrm>
+            <a:off x="2514600" y="1508760"/>
+            <a:ext cx="7132320" cy="3931920"/>
           </a:xfrm>
           <a:prstGeom prst="roundRect">
             <a:avLst>
-              <a:gd name="adj" fmla="val 2273"/>
+              <a:gd name="adj" fmla="val 2326"/>
             </a:avLst>
           </a:prstGeom>
           <a:solidFill>
@@ -4310,13 +4544,13 @@
       </p:sp>
       <p:sp>
         <p:nvSpPr>
-          <p:cNvPr id="4" name="Shape 2"/>
-          <p:cNvSpPr/>
-          <p:nvPr/>
-        </p:nvSpPr>
-        <p:spPr>
-          <a:xfrm>
-            <a:off x="5532120" y="3017520"/>
+          <p:cNvPr id="5" name="Shape 3"/>
+          <p:cNvSpPr/>
+          <p:nvPr/>
+        </p:nvSpPr>
+        <p:spPr>
+          <a:xfrm>
+            <a:off x="5532120" y="2926080"/>
             <a:ext cx="1097280" cy="1097280"/>
           </a:xfrm>
           <a:prstGeom prst="ellipse">
@@ -4330,13 +4564,13 @@
       </p:sp>
       <p:sp>
         <p:nvSpPr>
-          <p:cNvPr id="5" name="Shape 3"/>
+          <p:cNvPr id="6" name="Shape 4"/>
           <p:cNvSpPr/>
           <p:nvPr/>
         </p:nvSpPr>
         <p:spPr>
           <a:xfrm rot="5400000">
-            <a:off x="5916168" y="3310128"/>
+            <a:off x="5916168" y="3218688"/>
             <a:ext cx="512064" cy="512064"/>
           </a:xfrm>
           <a:prstGeom prst="triangle">
@@ -4350,14 +4584,14 @@
       </p:sp>
       <p:sp>
         <p:nvSpPr>
-          <p:cNvPr id="6" name="Text 4"/>
-          <p:cNvSpPr/>
-          <p:nvPr/>
-        </p:nvSpPr>
-        <p:spPr>
-          <a:xfrm>
-            <a:off x="2514600" y="5029200"/>
-            <a:ext cx="7132320" cy="411480"/>
+          <p:cNvPr id="7" name="Text 5"/>
+          <p:cNvSpPr/>
+          <p:nvPr/>
+        </p:nvSpPr>
+        <p:spPr>
+          <a:xfrm>
+            <a:off x="2514600" y="4937760"/>
+            <a:ext cx="7132320" cy="365760"/>
           </a:xfrm>
           <a:prstGeom prst="rect">
             <a:avLst/>
@@ -4427,6 +4661,45 @@
         </p:nvSpPr>
         <p:spPr>
           <a:xfrm>
+            <a:off x="822960" y="6419088"/>
+            <a:ext cx="5486400" cy="292608"/>
+          </a:xfrm>
+          <a:prstGeom prst="rect">
+            <a:avLst/>
+          </a:prstGeom>
+          <a:noFill/>
+          <a:ln/>
+        </p:spPr>
+        <p:txBody>
+          <a:bodyPr wrap="square" rtlCol="0" anchor="ctr"/>
+          <a:lstStyle/>
+          <a:p>
+            <a:pPr indent="0" marL="0">
+              <a:buNone/>
+            </a:pPr>
+            <a:r>
+              <a:rPr lang="en-US" sz="1100" spc="100" kern="0" dirty="0">
+                <a:solidFill>
+                  <a:srgbClr val="AAB4C0"/>
+                </a:solidFill>
+                <a:latin typeface="Calibri" pitchFamily="34" charset="0"/>
+                <a:ea typeface="Calibri" pitchFamily="34" charset="-122"/>
+                <a:cs typeface="Calibri" pitchFamily="34" charset="-120"/>
+              </a:rPr>
+              <a:t>arjunthakur.dev</a:t>
+            </a:r>
+            <a:endParaRPr lang="en-US" sz="1100" dirty="0"/>
+          </a:p>
+        </p:txBody>
+      </p:sp>
+      <p:sp>
+        <p:nvSpPr>
+          <p:cNvPr id="3" name="Text 1"/>
+          <p:cNvSpPr/>
+          <p:nvPr/>
+        </p:nvSpPr>
+        <p:spPr>
+          <a:xfrm>
             <a:off x="822960" y="777240"/>
             <a:ext cx="10515600" cy="822960"/>
           </a:xfrm>
@@ -4460,14 +4733,14 @@
       </p:sp>
       <p:sp>
         <p:nvSpPr>
-          <p:cNvPr id="3" name="animList"/>
+          <p:cNvPr id="4" name="animList"/>
           <p:cNvSpPr/>
           <p:nvPr/>
         </p:nvSpPr>
         <p:spPr>
           <a:xfrm>
             <a:off x="822960" y="2103120"/>
-            <a:ext cx="10241280" cy="3657600"/>
+            <a:ext cx="10241280" cy="3474720"/>
           </a:xfrm>
           <a:prstGeom prst="rect">
             <a:avLst/>
@@ -4621,7 +4894,7 @@
                                           </p:stCondLst>
                                         </p:cTn>
                                         <p:tgtEl>
-                                          <p:spTgt spid="3">
+                                          <p:spTgt spid="4">
                                             <p:txEl>
                                               <p:pRg st="0" end="0"/>
                                             </p:txEl>
@@ -4639,7 +4912,7 @@
                                       <p:cBhvr>
                                         <p:cTn id="7" dur="500"/>
                                         <p:tgtEl>
-                                          <p:spTgt spid="3">
+                                          <p:spTgt spid="4">
                                             <p:txEl>
                                               <p:pRg st="0" end="0"/>
                                             </p:txEl>
@@ -4682,7 +4955,7 @@
                                           </p:stCondLst>
                                         </p:cTn>
                                         <p:tgtEl>
-                                          <p:spTgt spid="3">
+                                          <p:spTgt spid="4">
                                             <p:txEl>
                                               <p:pRg st="1" end="1"/>
                                             </p:txEl>
@@ -4700,7 +4973,7 @@
                                       <p:cBhvr>
                                         <p:cTn id="12" dur="500"/>
                                         <p:tgtEl>
-                                          <p:spTgt spid="3">
+                                          <p:spTgt spid="4">
                                             <p:txEl>
                                               <p:pRg st="1" end="1"/>
                                             </p:txEl>
@@ -4743,7 +5016,7 @@
                                           </p:stCondLst>
                                         </p:cTn>
                                         <p:tgtEl>
-                                          <p:spTgt spid="3">
+                                          <p:spTgt spid="4">
                                             <p:txEl>
                                               <p:pRg st="2" end="2"/>
                                             </p:txEl>
@@ -4761,7 +5034,7 @@
                                       <p:cBhvr>
                                         <p:cTn id="17" dur="500"/>
                                         <p:tgtEl>
-                                          <p:spTgt spid="3">
+                                          <p:spTgt spid="4">
                                             <p:txEl>
                                               <p:pRg st="2" end="2"/>
                                             </p:txEl>
@@ -4800,7 +5073,7 @@
       </p:par>
     </p:tnLst>
     <p:bldLst>
-      <p:bldP spid="3" grpId="0" build="p"/>
+      <p:bldP spid="4" grpId="0" build="p"/>
     </p:bldLst>
   </p:timing>
 </p:sld>
@@ -4838,7 +5111,46 @@
         </p:nvSpPr>
         <p:spPr>
           <a:xfrm>
-            <a:off x="822960" y="1874520"/>
+            <a:off x="822960" y="6419088"/>
+            <a:ext cx="5486400" cy="292608"/>
+          </a:xfrm>
+          <a:prstGeom prst="rect">
+            <a:avLst/>
+          </a:prstGeom>
+          <a:noFill/>
+          <a:ln/>
+        </p:spPr>
+        <p:txBody>
+          <a:bodyPr wrap="square" rtlCol="0" anchor="ctr"/>
+          <a:lstStyle/>
+          <a:p>
+            <a:pPr indent="0" marL="0">
+              <a:buNone/>
+            </a:pPr>
+            <a:r>
+              <a:rPr lang="en-US" sz="1100" spc="100" kern="0" dirty="0">
+                <a:solidFill>
+                  <a:srgbClr val="AAB4C0"/>
+                </a:solidFill>
+                <a:latin typeface="Calibri" pitchFamily="34" charset="0"/>
+                <a:ea typeface="Calibri" pitchFamily="34" charset="-122"/>
+                <a:cs typeface="Calibri" pitchFamily="34" charset="-120"/>
+              </a:rPr>
+              <a:t>arjunthakur.dev</a:t>
+            </a:r>
+            <a:endParaRPr lang="en-US" sz="1100" dirty="0"/>
+          </a:p>
+        </p:txBody>
+      </p:sp>
+      <p:sp>
+        <p:nvSpPr>
+          <p:cNvPr id="3" name="Text 1"/>
+          <p:cNvSpPr/>
+          <p:nvPr/>
+        </p:nvSpPr>
+        <p:spPr>
+          <a:xfrm>
+            <a:off x="822960" y="2148840"/>
             <a:ext cx="9144000" cy="365760"/>
           </a:xfrm>
           <a:prstGeom prst="rect">
@@ -4871,13 +5183,13 @@
       </p:sp>
       <p:sp>
         <p:nvSpPr>
-          <p:cNvPr id="3" name="Text 1"/>
-          <p:cNvSpPr/>
-          <p:nvPr/>
-        </p:nvSpPr>
-        <p:spPr>
-          <a:xfrm>
-            <a:off x="822960" y="2240280"/>
+          <p:cNvPr id="4" name="Text 2"/>
+          <p:cNvSpPr/>
+          <p:nvPr/>
+        </p:nvSpPr>
+        <p:spPr>
+          <a:xfrm>
+            <a:off x="822960" y="2514600"/>
             <a:ext cx="10515600" cy="1188720"/>
           </a:xfrm>
           <a:prstGeom prst="rect">
@@ -4910,13 +5222,13 @@
       </p:sp>
       <p:sp>
         <p:nvSpPr>
-          <p:cNvPr id="4" name="Text 2"/>
-          <p:cNvSpPr/>
-          <p:nvPr/>
-        </p:nvSpPr>
-        <p:spPr>
-          <a:xfrm>
-            <a:off x="859536" y="3520440"/>
+          <p:cNvPr id="5" name="Text 3"/>
+          <p:cNvSpPr/>
+          <p:nvPr/>
+        </p:nvSpPr>
+        <p:spPr>
+          <a:xfrm>
+            <a:off x="859536" y="3794760"/>
             <a:ext cx="10515600" cy="548640"/>
           </a:xfrm>
           <a:prstGeom prst="rect">
@@ -4944,438 +5256,6 @@
               <a:t>Closing line — call to action goes here</a:t>
             </a:r>
             <a:endParaRPr lang="en-US" sz="2200" dirty="0"/>
-          </a:p>
-        </p:txBody>
-      </p:sp>
-      <p:sp>
-        <p:nvSpPr>
-          <p:cNvPr id="5" name="Shape 3"/>
-          <p:cNvSpPr/>
-          <p:nvPr/>
-        </p:nvSpPr>
-        <p:spPr>
-          <a:xfrm>
-            <a:off x="822960" y="5029200"/>
-            <a:ext cx="3566160" cy="868680"/>
-          </a:xfrm>
-          <a:prstGeom prst="roundRect">
-            <a:avLst>
-              <a:gd name="adj" fmla="val 9474"/>
-            </a:avLst>
-          </a:prstGeom>
-          <a:solidFill>
-            <a:srgbClr val="11161E"/>
-          </a:solidFill>
-          <a:ln w="12700">
-            <a:solidFill>
-              <a:srgbClr val="1F2937"/>
-            </a:solidFill>
-            <a:prstDash val="solid"/>
-          </a:ln>
-        </p:spPr>
-      </p:sp>
-      <p:sp>
-        <p:nvSpPr>
-          <p:cNvPr id="6" name="Text 4"/>
-          <p:cNvSpPr/>
-          <p:nvPr/>
-        </p:nvSpPr>
-        <p:spPr>
-          <a:xfrm>
-            <a:off x="950976" y="5047488"/>
-            <a:ext cx="640080" cy="822960"/>
-          </a:xfrm>
-          <a:prstGeom prst="rect">
-            <a:avLst/>
-          </a:prstGeom>
-          <a:noFill/>
-          <a:ln/>
-        </p:spPr>
-        <p:txBody>
-          <a:bodyPr wrap="square" rtlCol="0" anchor="ctr"/>
-          <a:lstStyle/>
-          <a:p>
-            <a:pPr algn="ctr" indent="0" marL="0">
-              <a:buNone/>
-            </a:pPr>
-            <a:r>
-              <a:rPr lang="en-US" sz="2000" dirty="0">
-                <a:solidFill>
-                  <a:srgbClr val="22D3EE"/>
-                </a:solidFill>
-                <a:latin typeface="Calibri" pitchFamily="34" charset="0"/>
-                <a:ea typeface="Calibri" pitchFamily="34" charset="-122"/>
-                <a:cs typeface="Calibri" pitchFamily="34" charset="-120"/>
-              </a:rPr>
-              <a:t>✉</a:t>
-            </a:r>
-            <a:endParaRPr lang="en-US" sz="2000" dirty="0"/>
-          </a:p>
-        </p:txBody>
-      </p:sp>
-      <p:sp>
-        <p:nvSpPr>
-          <p:cNvPr id="7" name="Text 5"/>
-          <p:cNvSpPr/>
-          <p:nvPr/>
-        </p:nvSpPr>
-        <p:spPr>
-          <a:xfrm>
-            <a:off x="1572768" y="5175504"/>
-            <a:ext cx="2697480" cy="274320"/>
-          </a:xfrm>
-          <a:prstGeom prst="rect">
-            <a:avLst/>
-          </a:prstGeom>
-          <a:noFill/>
-          <a:ln/>
-        </p:spPr>
-        <p:txBody>
-          <a:bodyPr wrap="square" lIns="0" tIns="0" rIns="0" bIns="0" rtlCol="0" anchor="ctr"/>
-          <a:lstStyle/>
-          <a:p>
-            <a:pPr indent="0" marL="0">
-              <a:buNone/>
-            </a:pPr>
-            <a:r>
-              <a:rPr lang="en-US" sz="1050" b="1" spc="100" kern="0" dirty="0">
-                <a:solidFill>
-                  <a:srgbClr val="AAB4C0"/>
-                </a:solidFill>
-                <a:latin typeface="Calibri" pitchFamily="34" charset="0"/>
-                <a:ea typeface="Calibri" pitchFamily="34" charset="-122"/>
-                <a:cs typeface="Calibri" pitchFamily="34" charset="-120"/>
-              </a:rPr>
-              <a:t>EMAIL</a:t>
-            </a:r>
-            <a:endParaRPr lang="en-US" sz="1050" dirty="0"/>
-          </a:p>
-        </p:txBody>
-      </p:sp>
-      <p:sp>
-        <p:nvSpPr>
-          <p:cNvPr id="8" name="Text 6"/>
-          <p:cNvSpPr/>
-          <p:nvPr/>
-        </p:nvSpPr>
-        <p:spPr>
-          <a:xfrm>
-            <a:off x="1572768" y="5431536"/>
-            <a:ext cx="2697480" cy="320040"/>
-          </a:xfrm>
-          <a:prstGeom prst="rect">
-            <a:avLst/>
-          </a:prstGeom>
-          <a:noFill/>
-          <a:ln/>
-        </p:spPr>
-        <p:txBody>
-          <a:bodyPr wrap="square" lIns="0" tIns="0" rIns="0" bIns="0" rtlCol="0" anchor="ctr"/>
-          <a:lstStyle/>
-          <a:p>
-            <a:pPr indent="0" marL="0">
-              <a:buNone/>
-            </a:pPr>
-            <a:r>
-              <a:rPr lang="en-US" sz="1300" dirty="0">
-                <a:solidFill>
-                  <a:srgbClr val="22D3EE"/>
-                </a:solidFill>
-                <a:latin typeface="Calibri" pitchFamily="34" charset="0"/>
-                <a:ea typeface="Calibri" pitchFamily="34" charset="-122"/>
-                <a:cs typeface="Calibri" pitchFamily="34" charset="-120"/>
-              </a:rPr>
-              <a:t>arjun@arjunthakur.dev</a:t>
-            </a:r>
-            <a:endParaRPr lang="en-US" sz="1300" dirty="0"/>
-          </a:p>
-        </p:txBody>
-      </p:sp>
-      <p:sp>
-        <p:nvSpPr>
-          <p:cNvPr id="9" name="Shape 7"/>
-          <p:cNvSpPr/>
-          <p:nvPr/>
-        </p:nvSpPr>
-        <p:spPr>
-          <a:xfrm>
-            <a:off x="4517136" y="5029200"/>
-            <a:ext cx="3063240" cy="868680"/>
-          </a:xfrm>
-          <a:prstGeom prst="roundRect">
-            <a:avLst>
-              <a:gd name="adj" fmla="val 9474"/>
-            </a:avLst>
-          </a:prstGeom>
-          <a:solidFill>
-            <a:srgbClr val="11161E"/>
-          </a:solidFill>
-          <a:ln w="12700">
-            <a:solidFill>
-              <a:srgbClr val="1F2937"/>
-            </a:solidFill>
-            <a:prstDash val="solid"/>
-          </a:ln>
-        </p:spPr>
-      </p:sp>
-      <p:sp>
-        <p:nvSpPr>
-          <p:cNvPr id="10" name="Text 8"/>
-          <p:cNvSpPr/>
-          <p:nvPr/>
-        </p:nvSpPr>
-        <p:spPr>
-          <a:xfrm>
-            <a:off x="4645152" y="5047488"/>
-            <a:ext cx="640080" cy="822960"/>
-          </a:xfrm>
-          <a:prstGeom prst="rect">
-            <a:avLst/>
-          </a:prstGeom>
-          <a:noFill/>
-          <a:ln/>
-        </p:spPr>
-        <p:txBody>
-          <a:bodyPr wrap="square" rtlCol="0" anchor="ctr"/>
-          <a:lstStyle/>
-          <a:p>
-            <a:pPr algn="ctr" indent="0" marL="0">
-              <a:buNone/>
-            </a:pPr>
-            <a:r>
-              <a:rPr lang="en-US" sz="2000" dirty="0">
-                <a:solidFill>
-                  <a:srgbClr val="22D3EE"/>
-                </a:solidFill>
-                <a:latin typeface="Calibri" pitchFamily="34" charset="0"/>
-                <a:ea typeface="Calibri" pitchFamily="34" charset="-122"/>
-                <a:cs typeface="Calibri" pitchFamily="34" charset="-120"/>
-              </a:rPr>
-              <a:t>◉</a:t>
-            </a:r>
-            <a:endParaRPr lang="en-US" sz="2000" dirty="0"/>
-          </a:p>
-        </p:txBody>
-      </p:sp>
-      <p:sp>
-        <p:nvSpPr>
-          <p:cNvPr id="11" name="Text 9"/>
-          <p:cNvSpPr/>
-          <p:nvPr/>
-        </p:nvSpPr>
-        <p:spPr>
-          <a:xfrm>
-            <a:off x="5266944" y="5175504"/>
-            <a:ext cx="2194560" cy="274320"/>
-          </a:xfrm>
-          <a:prstGeom prst="rect">
-            <a:avLst/>
-          </a:prstGeom>
-          <a:noFill/>
-          <a:ln/>
-        </p:spPr>
-        <p:txBody>
-          <a:bodyPr wrap="square" lIns="0" tIns="0" rIns="0" bIns="0" rtlCol="0" anchor="ctr"/>
-          <a:lstStyle/>
-          <a:p>
-            <a:pPr indent="0" marL="0">
-              <a:buNone/>
-            </a:pPr>
-            <a:r>
-              <a:rPr lang="en-US" sz="1050" b="1" spc="100" kern="0" dirty="0">
-                <a:solidFill>
-                  <a:srgbClr val="AAB4C0"/>
-                </a:solidFill>
-                <a:latin typeface="Calibri" pitchFamily="34" charset="0"/>
-                <a:ea typeface="Calibri" pitchFamily="34" charset="-122"/>
-                <a:cs typeface="Calibri" pitchFamily="34" charset="-120"/>
-              </a:rPr>
-              <a:t>WEBSITE</a:t>
-            </a:r>
-            <a:endParaRPr lang="en-US" sz="1050" dirty="0"/>
-          </a:p>
-        </p:txBody>
-      </p:sp>
-      <p:sp>
-        <p:nvSpPr>
-          <p:cNvPr id="12" name="Text 10"/>
-          <p:cNvSpPr/>
-          <p:nvPr/>
-        </p:nvSpPr>
-        <p:spPr>
-          <a:xfrm>
-            <a:off x="5266944" y="5431536"/>
-            <a:ext cx="2194560" cy="320040"/>
-          </a:xfrm>
-          <a:prstGeom prst="rect">
-            <a:avLst/>
-          </a:prstGeom>
-          <a:noFill/>
-          <a:ln/>
-        </p:spPr>
-        <p:txBody>
-          <a:bodyPr wrap="square" lIns="0" tIns="0" rIns="0" bIns="0" rtlCol="0" anchor="ctr"/>
-          <a:lstStyle/>
-          <a:p>
-            <a:pPr indent="0" marL="0">
-              <a:buNone/>
-            </a:pPr>
-            <a:r>
-              <a:rPr lang="en-US" sz="1300" dirty="0">
-                <a:solidFill>
-                  <a:srgbClr val="22D3EE"/>
-                </a:solidFill>
-                <a:latin typeface="Calibri" pitchFamily="34" charset="0"/>
-                <a:ea typeface="Calibri" pitchFamily="34" charset="-122"/>
-                <a:cs typeface="Calibri" pitchFamily="34" charset="-120"/>
-              </a:rPr>
-              <a:t>arjunthakur.dev</a:t>
-            </a:r>
-            <a:endParaRPr lang="en-US" sz="1300" dirty="0"/>
-          </a:p>
-        </p:txBody>
-      </p:sp>
-      <p:sp>
-        <p:nvSpPr>
-          <p:cNvPr id="13" name="Shape 11"/>
-          <p:cNvSpPr/>
-          <p:nvPr/>
-        </p:nvSpPr>
-        <p:spPr>
-          <a:xfrm>
-            <a:off x="7708392" y="5029200"/>
-            <a:ext cx="3657600" cy="868680"/>
-          </a:xfrm>
-          <a:prstGeom prst="roundRect">
-            <a:avLst>
-              <a:gd name="adj" fmla="val 9474"/>
-            </a:avLst>
-          </a:prstGeom>
-          <a:solidFill>
-            <a:srgbClr val="11161E"/>
-          </a:solidFill>
-          <a:ln w="12700">
-            <a:solidFill>
-              <a:srgbClr val="1F2937"/>
-            </a:solidFill>
-            <a:prstDash val="solid"/>
-          </a:ln>
-        </p:spPr>
-      </p:sp>
-      <p:sp>
-        <p:nvSpPr>
-          <p:cNvPr id="14" name="Text 12"/>
-          <p:cNvSpPr/>
-          <p:nvPr/>
-        </p:nvSpPr>
-        <p:spPr>
-          <a:xfrm>
-            <a:off x="7836408" y="5047488"/>
-            <a:ext cx="640080" cy="822960"/>
-          </a:xfrm>
-          <a:prstGeom prst="rect">
-            <a:avLst/>
-          </a:prstGeom>
-          <a:noFill/>
-          <a:ln/>
-        </p:spPr>
-        <p:txBody>
-          <a:bodyPr wrap="square" rtlCol="0" anchor="ctr"/>
-          <a:lstStyle/>
-          <a:p>
-            <a:pPr algn="ctr" indent="0" marL="0">
-              <a:buNone/>
-            </a:pPr>
-            <a:r>
-              <a:rPr lang="en-US" sz="2000" dirty="0">
-                <a:solidFill>
-                  <a:srgbClr val="22D3EE"/>
-                </a:solidFill>
-                <a:latin typeface="Calibri" pitchFamily="34" charset="0"/>
-                <a:ea typeface="Calibri" pitchFamily="34" charset="-122"/>
-                <a:cs typeface="Calibri" pitchFamily="34" charset="-120"/>
-              </a:rPr>
-              <a:t>■</a:t>
-            </a:r>
-            <a:endParaRPr lang="en-US" sz="2000" dirty="0"/>
-          </a:p>
-        </p:txBody>
-      </p:sp>
-      <p:sp>
-        <p:nvSpPr>
-          <p:cNvPr id="15" name="Text 13"/>
-          <p:cNvSpPr/>
-          <p:nvPr/>
-        </p:nvSpPr>
-        <p:spPr>
-          <a:xfrm>
-            <a:off x="8458200" y="5175504"/>
-            <a:ext cx="2788920" cy="274320"/>
-          </a:xfrm>
-          <a:prstGeom prst="rect">
-            <a:avLst/>
-          </a:prstGeom>
-          <a:noFill/>
-          <a:ln/>
-        </p:spPr>
-        <p:txBody>
-          <a:bodyPr wrap="square" lIns="0" tIns="0" rIns="0" bIns="0" rtlCol="0" anchor="ctr"/>
-          <a:lstStyle/>
-          <a:p>
-            <a:pPr indent="0" marL="0">
-              <a:buNone/>
-            </a:pPr>
-            <a:r>
-              <a:rPr lang="en-US" sz="1050" b="1" spc="100" kern="0" dirty="0">
-                <a:solidFill>
-                  <a:srgbClr val="AAB4C0"/>
-                </a:solidFill>
-                <a:latin typeface="Calibri" pitchFamily="34" charset="0"/>
-                <a:ea typeface="Calibri" pitchFamily="34" charset="-122"/>
-                <a:cs typeface="Calibri" pitchFamily="34" charset="-120"/>
-              </a:rPr>
-              <a:t>LINKEDIN</a:t>
-            </a:r>
-            <a:endParaRPr lang="en-US" sz="1050" dirty="0"/>
-          </a:p>
-        </p:txBody>
-      </p:sp>
-      <p:sp>
-        <p:nvSpPr>
-          <p:cNvPr id="16" name="Text 14"/>
-          <p:cNvSpPr/>
-          <p:nvPr/>
-        </p:nvSpPr>
-        <p:spPr>
-          <a:xfrm>
-            <a:off x="8458200" y="5431536"/>
-            <a:ext cx="2788920" cy="320040"/>
-          </a:xfrm>
-          <a:prstGeom prst="rect">
-            <a:avLst/>
-          </a:prstGeom>
-          <a:noFill/>
-          <a:ln/>
-        </p:spPr>
-        <p:txBody>
-          <a:bodyPr wrap="square" lIns="0" tIns="0" rIns="0" bIns="0" rtlCol="0" anchor="ctr"/>
-          <a:lstStyle/>
-          <a:p>
-            <a:pPr indent="0" marL="0">
-              <a:buNone/>
-            </a:pPr>
-            <a:r>
-              <a:rPr lang="en-US" sz="1300" dirty="0">
-                <a:solidFill>
-                  <a:srgbClr val="E6EDF3"/>
-                </a:solidFill>
-                <a:latin typeface="Calibri" pitchFamily="34" charset="0"/>
-                <a:ea typeface="Calibri" pitchFamily="34" charset="-122"/>
-                <a:cs typeface="Calibri" pitchFamily="34" charset="-120"/>
-              </a:rPr>
-              <a:t>in/thakurarjun247</a:t>
-            </a:r>
-            <a:endParaRPr lang="en-US" sz="1300" dirty="0"/>
           </a:p>
         </p:txBody>
       </p:sp>
@@ -5419,7 +5299,46 @@
         </p:nvSpPr>
         <p:spPr>
           <a:xfrm>
-            <a:off x="822960" y="1371600"/>
+            <a:off x="822960" y="6419088"/>
+            <a:ext cx="5486400" cy="292608"/>
+          </a:xfrm>
+          <a:prstGeom prst="rect">
+            <a:avLst/>
+          </a:prstGeom>
+          <a:noFill/>
+          <a:ln/>
+        </p:spPr>
+        <p:txBody>
+          <a:bodyPr wrap="square" rtlCol="0" anchor="ctr"/>
+          <a:lstStyle/>
+          <a:p>
+            <a:pPr indent="0" marL="0">
+              <a:buNone/>
+            </a:pPr>
+            <a:r>
+              <a:rPr lang="en-US" sz="1100" spc="100" kern="0" dirty="0">
+                <a:solidFill>
+                  <a:srgbClr val="AAB4C0"/>
+                </a:solidFill>
+                <a:latin typeface="Calibri" pitchFamily="34" charset="0"/>
+                <a:ea typeface="Calibri" pitchFamily="34" charset="-122"/>
+                <a:cs typeface="Calibri" pitchFamily="34" charset="-120"/>
+              </a:rPr>
+              <a:t>arjunthakur.dev</a:t>
+            </a:r>
+            <a:endParaRPr lang="en-US" sz="1100" dirty="0"/>
+          </a:p>
+        </p:txBody>
+      </p:sp>
+      <p:sp>
+        <p:nvSpPr>
+          <p:cNvPr id="3" name="Text 1"/>
+          <p:cNvSpPr/>
+          <p:nvPr/>
+        </p:nvSpPr>
+        <p:spPr>
+          <a:xfrm>
+            <a:off x="822960" y="1234440"/>
             <a:ext cx="9144000" cy="365760"/>
           </a:xfrm>
           <a:prstGeom prst="rect">
@@ -5452,13 +5371,13 @@
       </p:sp>
       <p:sp>
         <p:nvSpPr>
-          <p:cNvPr id="3" name="Text 1"/>
-          <p:cNvSpPr/>
-          <p:nvPr/>
-        </p:nvSpPr>
-        <p:spPr>
-          <a:xfrm>
-            <a:off x="822960" y="1737360"/>
+          <p:cNvPr id="4" name="Text 2"/>
+          <p:cNvSpPr/>
+          <p:nvPr/>
+        </p:nvSpPr>
+        <p:spPr>
+          <a:xfrm>
+            <a:off x="822960" y="1600200"/>
             <a:ext cx="10515600" cy="1188720"/>
           </a:xfrm>
           <a:prstGeom prst="rect">
@@ -5491,13 +5410,52 @@
       </p:sp>
       <p:sp>
         <p:nvSpPr>
-          <p:cNvPr id="4" name="Shape 2"/>
-          <p:cNvSpPr/>
-          <p:nvPr/>
-        </p:nvSpPr>
-        <p:spPr>
-          <a:xfrm>
-            <a:off x="822960" y="3840480"/>
+          <p:cNvPr id="5" name="Text 3"/>
+          <p:cNvSpPr/>
+          <p:nvPr/>
+        </p:nvSpPr>
+        <p:spPr>
+          <a:xfrm>
+            <a:off x="859536" y="3063240"/>
+            <a:ext cx="10058400" cy="365760"/>
+          </a:xfrm>
+          <a:prstGeom prst="rect">
+            <a:avLst/>
+          </a:prstGeom>
+          <a:noFill/>
+          <a:ln/>
+        </p:spPr>
+        <p:txBody>
+          <a:bodyPr wrap="square" rtlCol="0" anchor="ctr"/>
+          <a:lstStyle/>
+          <a:p>
+            <a:pPr indent="0" marL="0">
+              <a:buNone/>
+            </a:pPr>
+            <a:r>
+              <a:rPr lang="en-US" sz="1600" dirty="0">
+                <a:solidFill>
+                  <a:srgbClr val="AAB4C0"/>
+                </a:solidFill>
+                <a:latin typeface="Calibri" pitchFamily="34" charset="0"/>
+                <a:ea typeface="Calibri" pitchFamily="34" charset="-122"/>
+                <a:cs typeface="Calibri" pitchFamily="34" charset="-120"/>
+              </a:rPr>
+              <a:t>Reach me directly:</a:t>
+            </a:r>
+            <a:endParaRPr lang="en-US" sz="1600" dirty="0"/>
+          </a:p>
+        </p:txBody>
+      </p:sp>
+      <p:sp>
+        <p:nvSpPr>
+          <p:cNvPr id="6" name="Shape 4"/>
+          <p:cNvSpPr/>
+          <p:nvPr/>
+        </p:nvSpPr>
+        <p:spPr>
+          <a:xfrm>
+            <a:off x="822960" y="3611880"/>
             <a:ext cx="3566160" cy="868680"/>
           </a:xfrm>
           <a:prstGeom prst="roundRect">
@@ -5518,13 +5476,13 @@
       </p:sp>
       <p:sp>
         <p:nvSpPr>
-          <p:cNvPr id="5" name="Text 3"/>
-          <p:cNvSpPr/>
-          <p:nvPr/>
-        </p:nvSpPr>
-        <p:spPr>
-          <a:xfrm>
-            <a:off x="950976" y="3858768"/>
+          <p:cNvPr id="7" name="Text 5"/>
+          <p:cNvSpPr/>
+          <p:nvPr/>
+        </p:nvSpPr>
+        <p:spPr>
+          <a:xfrm>
+            <a:off x="950976" y="3630168"/>
             <a:ext cx="640080" cy="822960"/>
           </a:xfrm>
           <a:prstGeom prst="rect">
@@ -5557,13 +5515,13 @@
       </p:sp>
       <p:sp>
         <p:nvSpPr>
-          <p:cNvPr id="6" name="Text 4"/>
-          <p:cNvSpPr/>
-          <p:nvPr/>
-        </p:nvSpPr>
-        <p:spPr>
-          <a:xfrm>
-            <a:off x="1572768" y="3986784"/>
+          <p:cNvPr id="8" name="Text 6"/>
+          <p:cNvSpPr/>
+          <p:nvPr/>
+        </p:nvSpPr>
+        <p:spPr>
+          <a:xfrm>
+            <a:off x="1572768" y="3758184"/>
             <a:ext cx="2697480" cy="274320"/>
           </a:xfrm>
           <a:prstGeom prst="rect">
@@ -5596,13 +5554,13 @@
       </p:sp>
       <p:sp>
         <p:nvSpPr>
-          <p:cNvPr id="7" name="Text 5"/>
-          <p:cNvSpPr/>
-          <p:nvPr/>
-        </p:nvSpPr>
-        <p:spPr>
-          <a:xfrm>
-            <a:off x="1572768" y="4242816"/>
+          <p:cNvPr id="9" name="Text 7"/>
+          <p:cNvSpPr/>
+          <p:nvPr/>
+        </p:nvSpPr>
+        <p:spPr>
+          <a:xfrm>
+            <a:off x="1572768" y="4014216"/>
             <a:ext cx="2697480" cy="320040"/>
           </a:xfrm>
           <a:prstGeom prst="rect">
@@ -5635,13 +5593,13 @@
       </p:sp>
       <p:sp>
         <p:nvSpPr>
-          <p:cNvPr id="8" name="Shape 6"/>
-          <p:cNvSpPr/>
-          <p:nvPr/>
-        </p:nvSpPr>
-        <p:spPr>
-          <a:xfrm>
-            <a:off x="4517136" y="3840480"/>
+          <p:cNvPr id="10" name="Shape 8"/>
+          <p:cNvSpPr/>
+          <p:nvPr/>
+        </p:nvSpPr>
+        <p:spPr>
+          <a:xfrm>
+            <a:off x="4517136" y="3611880"/>
             <a:ext cx="3063240" cy="868680"/>
           </a:xfrm>
           <a:prstGeom prst="roundRect">
@@ -5662,13 +5620,13 @@
       </p:sp>
       <p:sp>
         <p:nvSpPr>
-          <p:cNvPr id="9" name="Text 7"/>
-          <p:cNvSpPr/>
-          <p:nvPr/>
-        </p:nvSpPr>
-        <p:spPr>
-          <a:xfrm>
-            <a:off x="4645152" y="3858768"/>
+          <p:cNvPr id="11" name="Text 9"/>
+          <p:cNvSpPr/>
+          <p:nvPr/>
+        </p:nvSpPr>
+        <p:spPr>
+          <a:xfrm>
+            <a:off x="4645152" y="3630168"/>
             <a:ext cx="640080" cy="822960"/>
           </a:xfrm>
           <a:prstGeom prst="rect">
@@ -5693,7 +5651,7 @@
                 <a:ea typeface="Calibri" pitchFamily="34" charset="-122"/>
                 <a:cs typeface="Calibri" pitchFamily="34" charset="-120"/>
               </a:rPr>
-              <a:t>◉</a:t>
+              <a:t>☎</a:t>
             </a:r>
             <a:endParaRPr lang="en-US" sz="2000" dirty="0"/>
           </a:p>
@@ -5701,13 +5659,13 @@
       </p:sp>
       <p:sp>
         <p:nvSpPr>
-          <p:cNvPr id="10" name="Text 8"/>
-          <p:cNvSpPr/>
-          <p:nvPr/>
-        </p:nvSpPr>
-        <p:spPr>
-          <a:xfrm>
-            <a:off x="5266944" y="3986784"/>
+          <p:cNvPr id="12" name="Text 10"/>
+          <p:cNvSpPr/>
+          <p:nvPr/>
+        </p:nvSpPr>
+        <p:spPr>
+          <a:xfrm>
+            <a:off x="5266944" y="3758184"/>
             <a:ext cx="2194560" cy="274320"/>
           </a:xfrm>
           <a:prstGeom prst="rect">
@@ -5732,7 +5690,7 @@
                 <a:ea typeface="Calibri" pitchFamily="34" charset="-122"/>
                 <a:cs typeface="Calibri" pitchFamily="34" charset="-120"/>
               </a:rPr>
-              <a:t>WEBSITE</a:t>
+              <a:t>PHONE</a:t>
             </a:r>
             <a:endParaRPr lang="en-US" sz="1050" dirty="0"/>
           </a:p>
@@ -5740,13 +5698,13 @@
       </p:sp>
       <p:sp>
         <p:nvSpPr>
-          <p:cNvPr id="11" name="Text 9"/>
-          <p:cNvSpPr/>
-          <p:nvPr/>
-        </p:nvSpPr>
-        <p:spPr>
-          <a:xfrm>
-            <a:off x="5266944" y="4242816"/>
+          <p:cNvPr id="13" name="Text 11"/>
+          <p:cNvSpPr/>
+          <p:nvPr/>
+        </p:nvSpPr>
+        <p:spPr>
+          <a:xfrm>
+            <a:off x="5266944" y="4014216"/>
             <a:ext cx="2194560" cy="320040"/>
           </a:xfrm>
           <a:prstGeom prst="rect">
@@ -5771,7 +5729,7 @@
                 <a:ea typeface="Calibri" pitchFamily="34" charset="-122"/>
                 <a:cs typeface="Calibri" pitchFamily="34" charset="-120"/>
               </a:rPr>
-              <a:t>arjunthakur.dev</a:t>
+              <a:t>+91 93401 58116</a:t>
             </a:r>
             <a:endParaRPr lang="en-US" sz="1300" dirty="0"/>
           </a:p>
@@ -5779,13 +5737,13 @@
       </p:sp>
       <p:sp>
         <p:nvSpPr>
-          <p:cNvPr id="12" name="Shape 10"/>
-          <p:cNvSpPr/>
-          <p:nvPr/>
-        </p:nvSpPr>
-        <p:spPr>
-          <a:xfrm>
-            <a:off x="7708392" y="3840480"/>
+          <p:cNvPr id="14" name="Shape 12"/>
+          <p:cNvSpPr/>
+          <p:nvPr/>
+        </p:nvSpPr>
+        <p:spPr>
+          <a:xfrm>
+            <a:off x="7708392" y="3611880"/>
             <a:ext cx="3657600" cy="868680"/>
           </a:xfrm>
           <a:prstGeom prst="roundRect">
@@ -5806,13 +5764,13 @@
       </p:sp>
       <p:sp>
         <p:nvSpPr>
-          <p:cNvPr id="13" name="Text 11"/>
-          <p:cNvSpPr/>
-          <p:nvPr/>
-        </p:nvSpPr>
-        <p:spPr>
-          <a:xfrm>
-            <a:off x="7836408" y="3858768"/>
+          <p:cNvPr id="15" name="Text 13"/>
+          <p:cNvSpPr/>
+          <p:nvPr/>
+        </p:nvSpPr>
+        <p:spPr>
+          <a:xfrm>
+            <a:off x="7836408" y="3630168"/>
             <a:ext cx="640080" cy="822960"/>
           </a:xfrm>
           <a:prstGeom prst="rect">
@@ -5837,7 +5795,7 @@
                 <a:ea typeface="Calibri" pitchFamily="34" charset="-122"/>
                 <a:cs typeface="Calibri" pitchFamily="34" charset="-120"/>
               </a:rPr>
-              <a:t>■</a:t>
+              <a:t>◉</a:t>
             </a:r>
             <a:endParaRPr lang="en-US" sz="2000" dirty="0"/>
           </a:p>
@@ -5845,13 +5803,13 @@
       </p:sp>
       <p:sp>
         <p:nvSpPr>
-          <p:cNvPr id="14" name="Text 12"/>
-          <p:cNvSpPr/>
-          <p:nvPr/>
-        </p:nvSpPr>
-        <p:spPr>
-          <a:xfrm>
-            <a:off x="8458200" y="3986784"/>
+          <p:cNvPr id="16" name="Text 14"/>
+          <p:cNvSpPr/>
+          <p:nvPr/>
+        </p:nvSpPr>
+        <p:spPr>
+          <a:xfrm>
+            <a:off x="8458200" y="3758184"/>
             <a:ext cx="2788920" cy="274320"/>
           </a:xfrm>
           <a:prstGeom prst="rect">
@@ -5876,7 +5834,7 @@
                 <a:ea typeface="Calibri" pitchFamily="34" charset="-122"/>
                 <a:cs typeface="Calibri" pitchFamily="34" charset="-120"/>
               </a:rPr>
-              <a:t>LINKEDIN</a:t>
+              <a:t>WEBSITE</a:t>
             </a:r>
             <a:endParaRPr lang="en-US" sz="1050" dirty="0"/>
           </a:p>
@@ -5884,13 +5842,13 @@
       </p:sp>
       <p:sp>
         <p:nvSpPr>
-          <p:cNvPr id="15" name="Text 13"/>
-          <p:cNvSpPr/>
-          <p:nvPr/>
-        </p:nvSpPr>
-        <p:spPr>
-          <a:xfrm>
-            <a:off x="8458200" y="4242816"/>
+          <p:cNvPr id="17" name="Text 15"/>
+          <p:cNvSpPr/>
+          <p:nvPr/>
+        </p:nvSpPr>
+        <p:spPr>
+          <a:xfrm>
+            <a:off x="8458200" y="4014216"/>
             <a:ext cx="2788920" cy="320040"/>
           </a:xfrm>
           <a:prstGeom prst="rect">
@@ -5909,54 +5867,15 @@
             <a:r>
               <a:rPr lang="en-US" sz="1300" dirty="0">
                 <a:solidFill>
-                  <a:srgbClr val="E6EDF3"/>
-                </a:solidFill>
-                <a:latin typeface="Calibri" pitchFamily="34" charset="0"/>
-                <a:ea typeface="Calibri" pitchFamily="34" charset="-122"/>
-                <a:cs typeface="Calibri" pitchFamily="34" charset="-120"/>
-              </a:rPr>
-              <a:t>in/thakurarjun247</a:t>
+                  <a:srgbClr val="22D3EE"/>
+                </a:solidFill>
+                <a:latin typeface="Calibri" pitchFamily="34" charset="0"/>
+                <a:ea typeface="Calibri" pitchFamily="34" charset="-122"/>
+                <a:cs typeface="Calibri" pitchFamily="34" charset="-120"/>
+              </a:rPr>
+              <a:t>arjunthakur.dev</a:t>
             </a:r>
             <a:endParaRPr lang="en-US" sz="1300" dirty="0"/>
-          </a:p>
-        </p:txBody>
-      </p:sp>
-      <p:sp>
-        <p:nvSpPr>
-          <p:cNvPr id="16" name="Text 14"/>
-          <p:cNvSpPr/>
-          <p:nvPr/>
-        </p:nvSpPr>
-        <p:spPr>
-          <a:xfrm>
-            <a:off x="859536" y="5852160"/>
-            <a:ext cx="10058400" cy="457200"/>
-          </a:xfrm>
-          <a:prstGeom prst="rect">
-            <a:avLst/>
-          </a:prstGeom>
-          <a:noFill/>
-          <a:ln/>
-        </p:spPr>
-        <p:txBody>
-          <a:bodyPr wrap="square" rtlCol="0" anchor="ctr"/>
-          <a:lstStyle/>
-          <a:p>
-            <a:pPr indent="0" marL="0">
-              <a:buNone/>
-            </a:pPr>
-            <a:r>
-              <a:rPr lang="en-US" sz="1400" i="1" dirty="0">
-                <a:solidFill>
-                  <a:srgbClr val="8592A3"/>
-                </a:solidFill>
-                <a:latin typeface="Calibri" pitchFamily="34" charset="0"/>
-                <a:ea typeface="Calibri" pitchFamily="34" charset="-122"/>
-                <a:cs typeface="Calibri" pitchFamily="34" charset="-120"/>
-              </a:rPr>
-              <a:t>Slides &amp; resources: arjunthakur.dev</a:t>
-            </a:r>
-            <a:endParaRPr lang="en-US" sz="1400" dirty="0"/>
           </a:p>
         </p:txBody>
       </p:sp>

</xml_diff>